<commit_message>
Update presentation and scripts to use local URLs (localhost:3000/dashboard) instead of domain
</commit_message>
<xml_diff>
--- a/AiSOC_Mini_Project_Presentation.pptx
+++ b/AiSOC_Mini_Project_Presentation.pptx
@@ -13948,7 +13948,7 @@
                   <a:srgbClr val="F8FAFC"/>
                 </a:solidFill>
               </a:rPr>
-              <a:t>tryaisoc.com/dashboard  (Active Multi-Tenant Web Console)</a:t>
+              <a:t>http://localhost:3000/dashboard  (Local Next.js + FastAPI Console)</a:t>
             </a:r>
           </a:p>
           <a:p>
@@ -13974,7 +13974,7 @@
                   <a:srgbClr val="F8FAFC"/>
                 </a:solidFill>
               </a:rPr>
-              <a:t>pip install aisoc-sandbox &amp;&amp; aisoc-sandbox demo  (&lt;30s cold-start execution)</a:t>
+              <a:t>pip install aisoc-sandbox &amp;&amp; aisoc-sandbox demo  (&lt;30s local execution)</a:t>
             </a:r>
           </a:p>
           <a:p>
@@ -14000,7 +14000,7 @@
                   <a:srgbClr val="F8FAFC"/>
                 </a:solidFill>
               </a:rPr>
-              <a:t>tryaisoc.com/docs  (Architecture, Graph Schema &amp; Connector Guides)</a:t>
+              <a:t>Local Architecture Docs, Graph Schema &amp; Connector Guides (docs/)</a:t>
             </a:r>
           </a:p>
           <a:p>

</xml_diff>